<commit_message>
Keep only the CTO deck
Remove the earlier long deck and its charts. The CTO deck builder now reads its numbers from presentation/deck_facts.py.
</commit_message>
<xml_diff>
--- a/presentation/SmartBin – CTO presentation.pptx
+++ b/presentation/SmartBin – CTO presentation.pptx
@@ -668,11 +668,6 @@
               <a:t>So the best setting cannot be looked up. Each scale has to learn it.</a:t>
             </a:r>
           </a:p>
-          <a:p>
-            <a:r>
-              <a:t>If the Power BI report is open, the factory page fits here.</a:t>
-            </a:r>
-          </a:p>
         </p:txBody>
       </p:sp>
       <p:sp>
@@ -2161,11 +2156,6 @@
           <a:p>
             <a:r>
               <a:t>The real question is how far we can go before we start missing picks.</a:t>
-            </a:r>
-          </a:p>
-          <a:p>
-            <a:r>
-              <a:t>If the Power BI report is open, this page can be shown live here.</a:t>
             </a:r>
           </a:p>
         </p:txBody>
@@ -12028,7 +12018,7 @@
                 </a:solidFill>
                 <a:latin typeface="DM Sans"/>
               </a:rPr>
-              <a:t>Show KPI 2.0 in the dashboard</a:t>
+              <a:t>Report KPI 2.0 for every scale</a:t>
             </a:r>
           </a:p>
         </p:txBody>
@@ -17515,7 +17505,7 @@
                           </a:solidFill>
                           <a:latin typeface="DM Sans"/>
                         </a:rPr>
-                        <a:t>tables for Power BI, figures, the written report and both decks</a:t>
+                        <a:t>summary tables, figures, the written report and this deck</a:t>
                       </a:r>
                     </a:p>
                   </a:txBody>
@@ -17848,7 +17838,7 @@
                 </a:solidFill>
                 <a:latin typeface="DM Sans"/>
               </a:rPr>
-              <a:t>Raw data and Power BI files never go into the repository – only summary tables.</a:t>
+              <a:t>Raw data never goes into the repository – only summary tables.</a:t>
             </a:r>
           </a:p>
         </p:txBody>
@@ -19649,7 +19639,7 @@
         <p:spPr>
           <a:xfrm>
             <a:off x="2884812" y="5618480"/>
-            <a:ext cx="996850" cy="310896"/>
+            <a:ext cx="887710" cy="310896"/>
           </a:xfrm>
           <a:prstGeom prst="roundRect">
             <a:avLst>
@@ -19681,7 +19671,7 @@
                 </a:solidFill>
                 <a:latin typeface="DM Sans"/>
               </a:rPr>
-              <a:t>Power BI</a:t>
+              <a:t>Quarto</a:t>
             </a:r>
           </a:p>
         </p:txBody>
@@ -19694,53 +19684,7 @@
         </p:nvSpPr>
         <p:spPr>
           <a:xfrm>
-            <a:off x="3991391" y="5618480"/>
-            <a:ext cx="887710" cy="310896"/>
-          </a:xfrm>
-          <a:prstGeom prst="roundRect">
-            <a:avLst>
-              <a:gd name="adj" fmla="val 50000"/>
-            </a:avLst>
-          </a:prstGeom>
-          <a:solidFill>
-            <a:srgbClr val="5EEAD4">
-              <a:alpha val="16000"/>
-            </a:srgbClr>
-          </a:solidFill>
-          <a:ln w="6350">
-            <a:solidFill>
-              <a:srgbClr val="5EEAD4">
-                <a:alpha val="45000"/>
-              </a:srgbClr>
-            </a:solidFill>
-          </a:ln>
-        </p:spPr>
-        <p:txBody>
-          <a:bodyPr rtlCol="0" anchor="ctr" lIns="45720" rIns="45720" tIns="0" bIns="0" wrap="none"/>
-          <a:lstStyle/>
-          <a:p>
-            <a:pPr algn="ctr"/>
-            <a:r>
-              <a:rPr sz="1200" b="1">
-                <a:solidFill>
-                  <a:srgbClr val="5EEAD4"/>
-                </a:solidFill>
-                <a:latin typeface="DM Sans"/>
-              </a:rPr>
-              <a:t>Quarto</a:t>
-            </a:r>
-          </a:p>
-        </p:txBody>
-      </p:sp>
-      <p:sp>
-        <p:nvSpPr>
-          <p:cNvPr id="36" name="Rounded Rectangle 35"/>
-          <p:cNvSpPr/>
-          <p:nvPr/>
-        </p:nvSpPr>
-        <p:spPr>
-          <a:xfrm>
-            <a:off x="4988829" y="5618480"/>
+            <a:off x="3882251" y="5618480"/>
             <a:ext cx="2587704" cy="310896"/>
           </a:xfrm>
           <a:prstGeom prst="roundRect">
@@ -19780,7 +19724,7 @@
       </p:sp>
       <p:sp>
         <p:nvSpPr>
-          <p:cNvPr id="37" name="TextBox 36"/>
+          <p:cNvPr id="36" name="TextBox 35"/>
           <p:cNvSpPr txBox="1"/>
           <p:nvPr/>
         </p:nvSpPr>
@@ -19819,7 +19763,7 @@
       </p:sp>
       <p:sp>
         <p:nvSpPr>
-          <p:cNvPr id="38" name="TextBox 37"/>
+          <p:cNvPr id="37" name="TextBox 36"/>
           <p:cNvSpPr txBox="1"/>
           <p:nvPr/>
         </p:nvSpPr>

</xml_diff>